<commit_message>
add: UML diagram for design/main*
</commit_message>
<xml_diff>
--- a/design/usecase-diagram/main.pptx
+++ b/design/usecase-diagram/main.pptx
@@ -243,7 +243,7 @@
           <a:p>
             <a:fld id="{895470F9-24F5-4294-9C89-B1EBC74BAF14}" type="datetimeFigureOut">
               <a:rPr lang="vi-VN" smtClean="0"/>
-              <a:t>25/03/2026</a:t>
+              <a:t>09/04/2026</a:t>
             </a:fld>
             <a:endParaRPr lang="vi-VN"/>
           </a:p>
@@ -413,7 +413,7 @@
           <a:p>
             <a:fld id="{895470F9-24F5-4294-9C89-B1EBC74BAF14}" type="datetimeFigureOut">
               <a:rPr lang="vi-VN" smtClean="0"/>
-              <a:t>25/03/2026</a:t>
+              <a:t>09/04/2026</a:t>
             </a:fld>
             <a:endParaRPr lang="vi-VN"/>
           </a:p>
@@ -593,7 +593,7 @@
           <a:p>
             <a:fld id="{895470F9-24F5-4294-9C89-B1EBC74BAF14}" type="datetimeFigureOut">
               <a:rPr lang="vi-VN" smtClean="0"/>
-              <a:t>25/03/2026</a:t>
+              <a:t>09/04/2026</a:t>
             </a:fld>
             <a:endParaRPr lang="vi-VN"/>
           </a:p>
@@ -763,7 +763,7 @@
           <a:p>
             <a:fld id="{895470F9-24F5-4294-9C89-B1EBC74BAF14}" type="datetimeFigureOut">
               <a:rPr lang="vi-VN" smtClean="0"/>
-              <a:t>25/03/2026</a:t>
+              <a:t>09/04/2026</a:t>
             </a:fld>
             <a:endParaRPr lang="vi-VN"/>
           </a:p>
@@ -1009,7 +1009,7 @@
           <a:p>
             <a:fld id="{895470F9-24F5-4294-9C89-B1EBC74BAF14}" type="datetimeFigureOut">
               <a:rPr lang="vi-VN" smtClean="0"/>
-              <a:t>25/03/2026</a:t>
+              <a:t>09/04/2026</a:t>
             </a:fld>
             <a:endParaRPr lang="vi-VN"/>
           </a:p>
@@ -1241,7 +1241,7 @@
           <a:p>
             <a:fld id="{895470F9-24F5-4294-9C89-B1EBC74BAF14}" type="datetimeFigureOut">
               <a:rPr lang="vi-VN" smtClean="0"/>
-              <a:t>25/03/2026</a:t>
+              <a:t>09/04/2026</a:t>
             </a:fld>
             <a:endParaRPr lang="vi-VN"/>
           </a:p>
@@ -1608,7 +1608,7 @@
           <a:p>
             <a:fld id="{895470F9-24F5-4294-9C89-B1EBC74BAF14}" type="datetimeFigureOut">
               <a:rPr lang="vi-VN" smtClean="0"/>
-              <a:t>25/03/2026</a:t>
+              <a:t>09/04/2026</a:t>
             </a:fld>
             <a:endParaRPr lang="vi-VN"/>
           </a:p>
@@ -1726,7 +1726,7 @@
           <a:p>
             <a:fld id="{895470F9-24F5-4294-9C89-B1EBC74BAF14}" type="datetimeFigureOut">
               <a:rPr lang="vi-VN" smtClean="0"/>
-              <a:t>25/03/2026</a:t>
+              <a:t>09/04/2026</a:t>
             </a:fld>
             <a:endParaRPr lang="vi-VN"/>
           </a:p>
@@ -1821,7 +1821,7 @@
           <a:p>
             <a:fld id="{895470F9-24F5-4294-9C89-B1EBC74BAF14}" type="datetimeFigureOut">
               <a:rPr lang="vi-VN" smtClean="0"/>
-              <a:t>25/03/2026</a:t>
+              <a:t>09/04/2026</a:t>
             </a:fld>
             <a:endParaRPr lang="vi-VN"/>
           </a:p>
@@ -2098,7 +2098,7 @@
           <a:p>
             <a:fld id="{895470F9-24F5-4294-9C89-B1EBC74BAF14}" type="datetimeFigureOut">
               <a:rPr lang="vi-VN" smtClean="0"/>
-              <a:t>25/03/2026</a:t>
+              <a:t>09/04/2026</a:t>
             </a:fld>
             <a:endParaRPr lang="vi-VN"/>
           </a:p>
@@ -2355,7 +2355,7 @@
           <a:p>
             <a:fld id="{895470F9-24F5-4294-9C89-B1EBC74BAF14}" type="datetimeFigureOut">
               <a:rPr lang="vi-VN" smtClean="0"/>
-              <a:t>25/03/2026</a:t>
+              <a:t>09/04/2026</a:t>
             </a:fld>
             <a:endParaRPr lang="vi-VN"/>
           </a:p>
@@ -2568,7 +2568,7 @@
           <a:p>
             <a:fld id="{895470F9-24F5-4294-9C89-B1EBC74BAF14}" type="datetimeFigureOut">
               <a:rPr lang="vi-VN" smtClean="0"/>
-              <a:t>25/03/2026</a:t>
+              <a:t>09/04/2026</a:t>
             </a:fld>
             <a:endParaRPr lang="vi-VN"/>
           </a:p>
@@ -4314,16 +4314,16 @@
           <a:p>
             <a:pPr algn="ctr"/>
             <a:r>
-              <a:rPr lang="en-US" dirty="0">
+              <a:rPr lang="en-US" sz="1200" dirty="0">
                 <a:solidFill>
                   <a:schemeClr val="accent2">
                     <a:lumMod val="75000"/>
                   </a:schemeClr>
                 </a:solidFill>
               </a:rPr>
-              <a:t>Proc. in for mem.</a:t>
-            </a:r>
-            <a:endParaRPr lang="vi-VN" dirty="0">
+              <a:t>Process in for members</a:t>
+            </a:r>
+            <a:endParaRPr lang="vi-VN" sz="1200" dirty="0">
               <a:solidFill>
                 <a:schemeClr val="accent2">
                   <a:lumMod val="75000"/>
@@ -4391,16 +4391,16 @@
           <a:p>
             <a:pPr algn="ctr"/>
             <a:r>
-              <a:rPr lang="en-US" dirty="0">
+              <a:rPr lang="en-US" sz="1200" dirty="0">
                 <a:solidFill>
                   <a:schemeClr val="accent2">
                     <a:lumMod val="75000"/>
                   </a:schemeClr>
                 </a:solidFill>
               </a:rPr>
-              <a:t>Proc. out for mem.</a:t>
-            </a:r>
-            <a:endParaRPr lang="vi-VN" dirty="0">
+              <a:t>Process out for members</a:t>
+            </a:r>
+            <a:endParaRPr lang="vi-VN" sz="1200" dirty="0">
               <a:solidFill>
                 <a:schemeClr val="accent2">
                   <a:lumMod val="75000"/>
@@ -4468,16 +4468,16 @@
           <a:p>
             <a:pPr algn="ctr"/>
             <a:r>
-              <a:rPr lang="en-US" dirty="0">
+              <a:rPr lang="en-US" sz="1200" dirty="0">
                 <a:solidFill>
                   <a:schemeClr val="accent2">
                     <a:lumMod val="75000"/>
                   </a:schemeClr>
                 </a:solidFill>
               </a:rPr>
-              <a:t>Parking subs. fee</a:t>
-            </a:r>
-            <a:endParaRPr lang="vi-VN" dirty="0">
+              <a:t>Pay on a recurring basis</a:t>
+            </a:r>
+            <a:endParaRPr lang="vi-VN" sz="1200" dirty="0">
               <a:solidFill>
                 <a:schemeClr val="accent2">
                   <a:lumMod val="75000"/>
@@ -4545,7 +4545,7 @@
           <a:p>
             <a:pPr algn="ctr"/>
             <a:r>
-              <a:rPr lang="en-US" dirty="0">
+              <a:rPr lang="en-US" sz="1200" dirty="0">
                 <a:solidFill>
                   <a:schemeClr val="accent4">
                     <a:lumMod val="75000"/>
@@ -4554,7 +4554,7 @@
               </a:rPr>
               <a:t>View empty slots</a:t>
             </a:r>
-            <a:endParaRPr lang="vi-VN" dirty="0">
+            <a:endParaRPr lang="vi-VN" sz="1200" dirty="0">
               <a:solidFill>
                 <a:schemeClr val="accent4">
                   <a:lumMod val="75000"/>
@@ -4622,16 +4622,16 @@
           <a:p>
             <a:pPr algn="ctr"/>
             <a:r>
-              <a:rPr lang="en-US" dirty="0">
+              <a:rPr lang="en-US" sz="1200" dirty="0">
                 <a:solidFill>
                   <a:schemeClr val="accent6">
                     <a:lumMod val="75000"/>
                   </a:schemeClr>
                 </a:solidFill>
               </a:rPr>
-              <a:t>Proc. in for guests</a:t>
-            </a:r>
-            <a:endParaRPr lang="vi-VN" dirty="0">
+              <a:t>Process in for guests</a:t>
+            </a:r>
+            <a:endParaRPr lang="vi-VN" sz="1200" dirty="0">
               <a:solidFill>
                 <a:schemeClr val="accent6">
                   <a:lumMod val="75000"/>
@@ -4699,16 +4699,16 @@
           <a:p>
             <a:pPr algn="ctr"/>
             <a:r>
-              <a:rPr lang="en-US" dirty="0">
+              <a:rPr lang="en-US" sz="1200" dirty="0">
                 <a:solidFill>
                   <a:schemeClr val="accent6">
                     <a:lumMod val="75000"/>
                   </a:schemeClr>
                 </a:solidFill>
               </a:rPr>
-              <a:t>Proc. out for guests</a:t>
-            </a:r>
-            <a:endParaRPr lang="vi-VN" dirty="0">
+              <a:t>Process out for guests</a:t>
+            </a:r>
+            <a:endParaRPr lang="vi-VN" sz="1200" dirty="0">
               <a:solidFill>
                 <a:schemeClr val="accent6">
                   <a:lumMod val="75000"/>
@@ -4776,16 +4776,16 @@
           <a:p>
             <a:pPr algn="ctr"/>
             <a:r>
-              <a:rPr lang="en-US" dirty="0">
+              <a:rPr lang="en-US" sz="1200" dirty="0">
                 <a:solidFill>
                   <a:schemeClr val="accent6">
                     <a:lumMod val="75000"/>
                   </a:schemeClr>
                 </a:solidFill>
               </a:rPr>
-              <a:t>Pay via QR/Cash</a:t>
-            </a:r>
-            <a:endParaRPr lang="vi-VN" dirty="0">
+              <a:t>Guests pay via QR/Cash</a:t>
+            </a:r>
+            <a:endParaRPr lang="vi-VN" sz="1200" dirty="0">
               <a:solidFill>
                 <a:schemeClr val="accent6">
                   <a:lumMod val="75000"/>
@@ -4853,16 +4853,16 @@
           <a:p>
             <a:pPr algn="ctr"/>
             <a:r>
-              <a:rPr lang="en-US" dirty="0">
+              <a:rPr lang="en-US" sz="1200" dirty="0">
                 <a:solidFill>
                   <a:schemeClr val="accent5">
                     <a:lumMod val="75000"/>
                   </a:schemeClr>
                 </a:solidFill>
               </a:rPr>
-              <a:t>Monitor/conf. sys.</a:t>
-            </a:r>
-            <a:endParaRPr lang="vi-VN" dirty="0">
+              <a:t>Monitor/configure system</a:t>
+            </a:r>
+            <a:endParaRPr lang="vi-VN" sz="1200" dirty="0">
               <a:solidFill>
                 <a:schemeClr val="accent5">
                   <a:lumMod val="75000"/>
@@ -4927,14 +4927,14 @@
           <a:p>
             <a:pPr algn="ctr"/>
             <a:r>
-              <a:rPr lang="en-US" dirty="0">
+              <a:rPr lang="en-US" sz="1200" dirty="0">
                 <a:solidFill>
                   <a:schemeClr val="tx1"/>
                 </a:solidFill>
               </a:rPr>
-              <a:t>Auth. members</a:t>
-            </a:r>
-            <a:endParaRPr lang="vi-VN" dirty="0">
+              <a:t>Authenticate members</a:t>
+            </a:r>
+            <a:endParaRPr lang="vi-VN" sz="1200" dirty="0">
               <a:solidFill>
                 <a:schemeClr val="tx1"/>
               </a:solidFill>
@@ -5000,16 +5000,16 @@
           <a:p>
             <a:pPr algn="ctr"/>
             <a:r>
-              <a:rPr lang="en-US" dirty="0">
+              <a:rPr lang="en-US" sz="1200" dirty="0">
                 <a:solidFill>
                   <a:schemeClr val="accent4">
                     <a:lumMod val="75000"/>
                   </a:schemeClr>
                 </a:solidFill>
               </a:rPr>
-              <a:t>Spec. occ. handling</a:t>
-            </a:r>
-            <a:endParaRPr lang="vi-VN" dirty="0">
+              <a:t>Special occurrence handling</a:t>
+            </a:r>
+            <a:endParaRPr lang="vi-VN" sz="1200" dirty="0">
               <a:solidFill>
                 <a:schemeClr val="accent4">
                   <a:lumMod val="75000"/>

</xml_diff>